<commit_message>
most experiment global, tournament
</commit_message>
<xml_diff>
--- a/weekly update.pptx
+++ b/weekly update.pptx
@@ -5,7 +5,7 @@
     <p:sldMasterId id="2147483648" r:id="rId1"/>
   </p:sldMasterIdLst>
   <p:notesMasterIdLst>
-    <p:notesMasterId r:id="rId7"/>
+    <p:notesMasterId r:id="rId8"/>
   </p:notesMasterIdLst>
   <p:sldIdLst>
     <p:sldId id="256" r:id="rId2"/>
@@ -13,6 +13,7 @@
     <p:sldId id="258" r:id="rId4"/>
     <p:sldId id="259" r:id="rId5"/>
     <p:sldId id="260" r:id="rId6"/>
+    <p:sldId id="261" r:id="rId7"/>
   </p:sldIdLst>
   <p:sldSz cx="12192000" cy="6858000"/>
   <p:notesSz cx="6858000" cy="9144000"/>
@@ -201,7 +202,7 @@
           <a:p>
             <a:fld id="{6CE0BCC4-4E28-4555-A894-ACF663B10A61}" type="datetimeFigureOut">
               <a:rPr lang="en-NZ" smtClean="0"/>
-              <a:t>30/03/2026</a:t>
+              <a:t>7/05/2026</a:t>
             </a:fld>
             <a:endParaRPr lang="en-NZ"/>
           </a:p>
@@ -702,7 +703,7 @@
           <a:p>
             <a:fld id="{470BFE98-226A-4904-8E3B-46F4BEED3314}" type="datetimeFigureOut">
               <a:rPr lang="en-NZ" smtClean="0"/>
-              <a:t>30/03/2026</a:t>
+              <a:t>7/05/2026</a:t>
             </a:fld>
             <a:endParaRPr lang="en-NZ"/>
           </a:p>
@@ -902,7 +903,7 @@
           <a:p>
             <a:fld id="{470BFE98-226A-4904-8E3B-46F4BEED3314}" type="datetimeFigureOut">
               <a:rPr lang="en-NZ" smtClean="0"/>
-              <a:t>30/03/2026</a:t>
+              <a:t>7/05/2026</a:t>
             </a:fld>
             <a:endParaRPr lang="en-NZ"/>
           </a:p>
@@ -1112,7 +1113,7 @@
           <a:p>
             <a:fld id="{470BFE98-226A-4904-8E3B-46F4BEED3314}" type="datetimeFigureOut">
               <a:rPr lang="en-NZ" smtClean="0"/>
-              <a:t>30/03/2026</a:t>
+              <a:t>7/05/2026</a:t>
             </a:fld>
             <a:endParaRPr lang="en-NZ"/>
           </a:p>
@@ -1312,7 +1313,7 @@
           <a:p>
             <a:fld id="{470BFE98-226A-4904-8E3B-46F4BEED3314}" type="datetimeFigureOut">
               <a:rPr lang="en-NZ" smtClean="0"/>
-              <a:t>30/03/2026</a:t>
+              <a:t>7/05/2026</a:t>
             </a:fld>
             <a:endParaRPr lang="en-NZ"/>
           </a:p>
@@ -1588,7 +1589,7 @@
           <a:p>
             <a:fld id="{470BFE98-226A-4904-8E3B-46F4BEED3314}" type="datetimeFigureOut">
               <a:rPr lang="en-NZ" smtClean="0"/>
-              <a:t>30/03/2026</a:t>
+              <a:t>7/05/2026</a:t>
             </a:fld>
             <a:endParaRPr lang="en-NZ"/>
           </a:p>
@@ -1856,7 +1857,7 @@
           <a:p>
             <a:fld id="{470BFE98-226A-4904-8E3B-46F4BEED3314}" type="datetimeFigureOut">
               <a:rPr lang="en-NZ" smtClean="0"/>
-              <a:t>30/03/2026</a:t>
+              <a:t>7/05/2026</a:t>
             </a:fld>
             <a:endParaRPr lang="en-NZ"/>
           </a:p>
@@ -2271,7 +2272,7 @@
           <a:p>
             <a:fld id="{470BFE98-226A-4904-8E3B-46F4BEED3314}" type="datetimeFigureOut">
               <a:rPr lang="en-NZ" smtClean="0"/>
-              <a:t>30/03/2026</a:t>
+              <a:t>7/05/2026</a:t>
             </a:fld>
             <a:endParaRPr lang="en-NZ"/>
           </a:p>
@@ -2413,7 +2414,7 @@
           <a:p>
             <a:fld id="{470BFE98-226A-4904-8E3B-46F4BEED3314}" type="datetimeFigureOut">
               <a:rPr lang="en-NZ" smtClean="0"/>
-              <a:t>30/03/2026</a:t>
+              <a:t>7/05/2026</a:t>
             </a:fld>
             <a:endParaRPr lang="en-NZ"/>
           </a:p>
@@ -2526,7 +2527,7 @@
           <a:p>
             <a:fld id="{470BFE98-226A-4904-8E3B-46F4BEED3314}" type="datetimeFigureOut">
               <a:rPr lang="en-NZ" smtClean="0"/>
-              <a:t>30/03/2026</a:t>
+              <a:t>7/05/2026</a:t>
             </a:fld>
             <a:endParaRPr lang="en-NZ"/>
           </a:p>
@@ -2839,7 +2840,7 @@
           <a:p>
             <a:fld id="{470BFE98-226A-4904-8E3B-46F4BEED3314}" type="datetimeFigureOut">
               <a:rPr lang="en-NZ" smtClean="0"/>
-              <a:t>30/03/2026</a:t>
+              <a:t>7/05/2026</a:t>
             </a:fld>
             <a:endParaRPr lang="en-NZ"/>
           </a:p>
@@ -3128,7 +3129,7 @@
           <a:p>
             <a:fld id="{470BFE98-226A-4904-8E3B-46F4BEED3314}" type="datetimeFigureOut">
               <a:rPr lang="en-NZ" smtClean="0"/>
-              <a:t>30/03/2026</a:t>
+              <a:t>7/05/2026</a:t>
             </a:fld>
             <a:endParaRPr lang="en-NZ"/>
           </a:p>
@@ -3371,7 +3372,7 @@
           <a:p>
             <a:fld id="{470BFE98-226A-4904-8E3B-46F4BEED3314}" type="datetimeFigureOut">
               <a:rPr lang="en-NZ" smtClean="0"/>
-              <a:t>30/03/2026</a:t>
+              <a:t>7/05/2026</a:t>
             </a:fld>
             <a:endParaRPr lang="en-NZ"/>
           </a:p>
@@ -4862,6 +4863,391 @@
     <p:extLst>
       <p:ext uri="{BB962C8B-B14F-4D97-AF65-F5344CB8AC3E}">
         <p14:creationId xmlns:p14="http://schemas.microsoft.com/office/powerpoint/2010/main" val="1964054132"/>
+      </p:ext>
+    </p:extLst>
+  </p:cSld>
+  <p:clrMapOvr>
+    <a:masterClrMapping/>
+  </p:clrMapOvr>
+</p:sld>
+</file>
+
+<file path=ppt/slides/slide6.xml><?xml version="1.0" encoding="utf-8"?>
+<p:sld xmlns:a="http://schemas.openxmlformats.org/drawingml/2006/main" xmlns:r="http://schemas.openxmlformats.org/officeDocument/2006/relationships" xmlns:p="http://schemas.openxmlformats.org/presentationml/2006/main">
+  <p:cSld>
+    <p:spTree>
+      <p:nvGrpSpPr>
+        <p:cNvPr id="1" name=""/>
+        <p:cNvGrpSpPr/>
+        <p:nvPr/>
+      </p:nvGrpSpPr>
+      <p:grpSpPr>
+        <a:xfrm>
+          <a:off x="0" y="0"/>
+          <a:ext cx="0" cy="0"/>
+          <a:chOff x="0" y="0"/>
+          <a:chExt cx="0" cy="0"/>
+        </a:xfrm>
+      </p:grpSpPr>
+      <p:pic>
+        <p:nvPicPr>
+          <p:cNvPr id="5" name="Picture 4">
+            <a:extLst>
+              <a:ext uri="{FF2B5EF4-FFF2-40B4-BE49-F238E27FC236}">
+                <a16:creationId xmlns:a16="http://schemas.microsoft.com/office/drawing/2014/main" id="{BBC98035-474D-6D68-5961-6A92196D7EB2}"/>
+              </a:ext>
+            </a:extLst>
+          </p:cNvPr>
+          <p:cNvPicPr>
+            <a:picLocks noChangeAspect="1"/>
+          </p:cNvPicPr>
+          <p:nvPr/>
+        </p:nvPicPr>
+        <p:blipFill>
+          <a:blip r:embed="rId2">
+            <a:extLst>
+              <a:ext uri="{28A0092B-C50C-407E-A947-70E740481C1C}">
+                <a14:useLocalDpi xmlns:a14="http://schemas.microsoft.com/office/drawing/2010/main" val="0"/>
+              </a:ext>
+            </a:extLst>
+          </a:blip>
+          <a:stretch>
+            <a:fillRect/>
+          </a:stretch>
+        </p:blipFill>
+        <p:spPr>
+          <a:xfrm>
+            <a:off x="221185" y="381000"/>
+            <a:ext cx="5898681" cy="2949341"/>
+          </a:xfrm>
+          <a:prstGeom prst="rect">
+            <a:avLst/>
+          </a:prstGeom>
+        </p:spPr>
+      </p:pic>
+      <p:sp>
+        <p:nvSpPr>
+          <p:cNvPr id="6" name="TextBox 5">
+            <a:extLst>
+              <a:ext uri="{FF2B5EF4-FFF2-40B4-BE49-F238E27FC236}">
+                <a16:creationId xmlns:a16="http://schemas.microsoft.com/office/drawing/2014/main" id="{5AD7F887-F9BF-73C7-737A-C26A29F28312}"/>
+              </a:ext>
+            </a:extLst>
+          </p:cNvPr>
+          <p:cNvSpPr txBox="1"/>
+          <p:nvPr/>
+        </p:nvSpPr>
+        <p:spPr>
+          <a:xfrm>
+            <a:off x="2646751" y="2954956"/>
+            <a:ext cx="1705793" cy="369332"/>
+          </a:xfrm>
+          <a:prstGeom prst="rect">
+            <a:avLst/>
+          </a:prstGeom>
+          <a:noFill/>
+        </p:spPr>
+        <p:txBody>
+          <a:bodyPr wrap="square" rtlCol="0">
+            <a:spAutoFit/>
+          </a:bodyPr>
+          <a:lstStyle/>
+          <a:p>
+            <a:r>
+              <a:rPr lang="en-NZ" dirty="0"/>
+              <a:t>N = 5 (14)</a:t>
+            </a:r>
+          </a:p>
+        </p:txBody>
+      </p:sp>
+      <p:pic>
+        <p:nvPicPr>
+          <p:cNvPr id="8" name="Picture 7">
+            <a:extLst>
+              <a:ext uri="{FF2B5EF4-FFF2-40B4-BE49-F238E27FC236}">
+                <a16:creationId xmlns:a16="http://schemas.microsoft.com/office/drawing/2014/main" id="{8C097249-0467-9C7B-C6FA-360320E17EE9}"/>
+              </a:ext>
+            </a:extLst>
+          </p:cNvPr>
+          <p:cNvPicPr>
+            <a:picLocks noChangeAspect="1"/>
+          </p:cNvPicPr>
+          <p:nvPr/>
+        </p:nvPicPr>
+        <p:blipFill>
+          <a:blip r:embed="rId3">
+            <a:extLst>
+              <a:ext uri="{28A0092B-C50C-407E-A947-70E740481C1C}">
+                <a14:useLocalDpi xmlns:a14="http://schemas.microsoft.com/office/drawing/2010/main" val="0"/>
+              </a:ext>
+            </a:extLst>
+          </a:blip>
+          <a:stretch>
+            <a:fillRect/>
+          </a:stretch>
+        </p:blipFill>
+        <p:spPr>
+          <a:xfrm>
+            <a:off x="6068568" y="252984"/>
+            <a:ext cx="6096000" cy="3048000"/>
+          </a:xfrm>
+          <a:prstGeom prst="rect">
+            <a:avLst/>
+          </a:prstGeom>
+        </p:spPr>
+      </p:pic>
+      <p:sp>
+        <p:nvSpPr>
+          <p:cNvPr id="11" name="TextBox 10">
+            <a:extLst>
+              <a:ext uri="{FF2B5EF4-FFF2-40B4-BE49-F238E27FC236}">
+                <a16:creationId xmlns:a16="http://schemas.microsoft.com/office/drawing/2014/main" id="{29477A88-5A5A-59EB-906D-05FA72C1EA6B}"/>
+              </a:ext>
+            </a:extLst>
+          </p:cNvPr>
+          <p:cNvSpPr txBox="1"/>
+          <p:nvPr/>
+        </p:nvSpPr>
+        <p:spPr>
+          <a:xfrm>
+            <a:off x="8906674" y="2954956"/>
+            <a:ext cx="770217" cy="369332"/>
+          </a:xfrm>
+          <a:prstGeom prst="rect">
+            <a:avLst/>
+          </a:prstGeom>
+          <a:noFill/>
+        </p:spPr>
+        <p:txBody>
+          <a:bodyPr wrap="square" rtlCol="0">
+            <a:spAutoFit/>
+          </a:bodyPr>
+          <a:lstStyle/>
+          <a:p>
+            <a:r>
+              <a:rPr lang="en-NZ" dirty="0"/>
+              <a:t>N = 4</a:t>
+            </a:r>
+          </a:p>
+        </p:txBody>
+      </p:sp>
+      <p:pic>
+        <p:nvPicPr>
+          <p:cNvPr id="13" name="Picture 12">
+            <a:extLst>
+              <a:ext uri="{FF2B5EF4-FFF2-40B4-BE49-F238E27FC236}">
+                <a16:creationId xmlns:a16="http://schemas.microsoft.com/office/drawing/2014/main" id="{454C02DA-CA48-4559-D47D-322D5A227C8A}"/>
+              </a:ext>
+            </a:extLst>
+          </p:cNvPr>
+          <p:cNvPicPr>
+            <a:picLocks noChangeAspect="1"/>
+          </p:cNvPicPr>
+          <p:nvPr/>
+        </p:nvPicPr>
+        <p:blipFill>
+          <a:blip r:embed="rId4">
+            <a:extLst>
+              <a:ext uri="{28A0092B-C50C-407E-A947-70E740481C1C}">
+                <a14:useLocalDpi xmlns:a14="http://schemas.microsoft.com/office/drawing/2010/main" val="0"/>
+              </a:ext>
+            </a:extLst>
+          </a:blip>
+          <a:stretch>
+            <a:fillRect/>
+          </a:stretch>
+        </p:blipFill>
+        <p:spPr>
+          <a:xfrm>
+            <a:off x="0" y="3324288"/>
+            <a:ext cx="6305424" cy="3152712"/>
+          </a:xfrm>
+          <a:prstGeom prst="rect">
+            <a:avLst/>
+          </a:prstGeom>
+        </p:spPr>
+      </p:pic>
+      <p:pic>
+        <p:nvPicPr>
+          <p:cNvPr id="14" name="Picture 13">
+            <a:extLst>
+              <a:ext uri="{FF2B5EF4-FFF2-40B4-BE49-F238E27FC236}">
+                <a16:creationId xmlns:a16="http://schemas.microsoft.com/office/drawing/2014/main" id="{1E0C18F5-8156-9365-4B28-DF4CA8EAB2F4}"/>
+              </a:ext>
+            </a:extLst>
+          </p:cNvPr>
+          <p:cNvPicPr>
+            <a:picLocks noChangeAspect="1"/>
+          </p:cNvPicPr>
+          <p:nvPr/>
+        </p:nvPicPr>
+        <p:blipFill>
+          <a:blip r:embed="rId3">
+            <a:extLst>
+              <a:ext uri="{28A0092B-C50C-407E-A947-70E740481C1C}">
+                <a14:useLocalDpi xmlns:a14="http://schemas.microsoft.com/office/drawing/2010/main" val="0"/>
+              </a:ext>
+            </a:extLst>
+          </a:blip>
+          <a:stretch>
+            <a:fillRect/>
+          </a:stretch>
+        </p:blipFill>
+        <p:spPr>
+          <a:xfrm>
+            <a:off x="6056807" y="229680"/>
+            <a:ext cx="6096000" cy="3048000"/>
+          </a:xfrm>
+          <a:prstGeom prst="rect">
+            <a:avLst/>
+          </a:prstGeom>
+        </p:spPr>
+      </p:pic>
+      <p:sp>
+        <p:nvSpPr>
+          <p:cNvPr id="15" name="TextBox 14">
+            <a:extLst>
+              <a:ext uri="{FF2B5EF4-FFF2-40B4-BE49-F238E27FC236}">
+                <a16:creationId xmlns:a16="http://schemas.microsoft.com/office/drawing/2014/main" id="{7D06ACCD-1BA4-7FE2-F6CA-B5F34ED5CEDF}"/>
+              </a:ext>
+            </a:extLst>
+          </p:cNvPr>
+          <p:cNvSpPr txBox="1"/>
+          <p:nvPr/>
+        </p:nvSpPr>
+        <p:spPr>
+          <a:xfrm>
+            <a:off x="8894913" y="2931652"/>
+            <a:ext cx="1253284" cy="369332"/>
+          </a:xfrm>
+          <a:prstGeom prst="rect">
+            <a:avLst/>
+          </a:prstGeom>
+          <a:noFill/>
+        </p:spPr>
+        <p:txBody>
+          <a:bodyPr wrap="square" rtlCol="0">
+            <a:spAutoFit/>
+          </a:bodyPr>
+          <a:lstStyle/>
+          <a:p>
+            <a:r>
+              <a:rPr lang="en-NZ" dirty="0"/>
+              <a:t>N = 4 (10)</a:t>
+            </a:r>
+          </a:p>
+        </p:txBody>
+      </p:sp>
+      <p:sp>
+        <p:nvSpPr>
+          <p:cNvPr id="16" name="TextBox 15">
+            <a:extLst>
+              <a:ext uri="{FF2B5EF4-FFF2-40B4-BE49-F238E27FC236}">
+                <a16:creationId xmlns:a16="http://schemas.microsoft.com/office/drawing/2014/main" id="{D9F73F01-CCB7-9425-E12D-35B5DCF7FE75}"/>
+              </a:ext>
+            </a:extLst>
+          </p:cNvPr>
+          <p:cNvSpPr txBox="1"/>
+          <p:nvPr/>
+        </p:nvSpPr>
+        <p:spPr>
+          <a:xfrm>
+            <a:off x="2755724" y="6051612"/>
+            <a:ext cx="1212772" cy="369332"/>
+          </a:xfrm>
+          <a:prstGeom prst="rect">
+            <a:avLst/>
+          </a:prstGeom>
+          <a:noFill/>
+        </p:spPr>
+        <p:txBody>
+          <a:bodyPr wrap="square" rtlCol="0">
+            <a:spAutoFit/>
+          </a:bodyPr>
+          <a:lstStyle/>
+          <a:p>
+            <a:r>
+              <a:rPr lang="en-NZ" dirty="0"/>
+              <a:t>N = 2 (10)</a:t>
+            </a:r>
+          </a:p>
+        </p:txBody>
+      </p:sp>
+      <p:pic>
+        <p:nvPicPr>
+          <p:cNvPr id="18" name="Picture 17">
+            <a:extLst>
+              <a:ext uri="{FF2B5EF4-FFF2-40B4-BE49-F238E27FC236}">
+                <a16:creationId xmlns:a16="http://schemas.microsoft.com/office/drawing/2014/main" id="{541F616A-85DD-73DE-5597-84EA1E8979B3}"/>
+              </a:ext>
+            </a:extLst>
+          </p:cNvPr>
+          <p:cNvPicPr>
+            <a:picLocks noChangeAspect="1"/>
+          </p:cNvPicPr>
+          <p:nvPr/>
+        </p:nvPicPr>
+        <p:blipFill>
+          <a:blip r:embed="rId5">
+            <a:extLst>
+              <a:ext uri="{28A0092B-C50C-407E-A947-70E740481C1C}">
+                <a14:useLocalDpi xmlns:a14="http://schemas.microsoft.com/office/drawing/2010/main" val="0"/>
+              </a:ext>
+            </a:extLst>
+          </a:blip>
+          <a:stretch>
+            <a:fillRect/>
+          </a:stretch>
+        </p:blipFill>
+        <p:spPr>
+          <a:xfrm>
+            <a:off x="6160830" y="3429000"/>
+            <a:ext cx="5927538" cy="2963769"/>
+          </a:xfrm>
+          <a:prstGeom prst="rect">
+            <a:avLst/>
+          </a:prstGeom>
+        </p:spPr>
+      </p:pic>
+      <p:sp>
+        <p:nvSpPr>
+          <p:cNvPr id="25" name="TextBox 24">
+            <a:extLst>
+              <a:ext uri="{FF2B5EF4-FFF2-40B4-BE49-F238E27FC236}">
+                <a16:creationId xmlns:a16="http://schemas.microsoft.com/office/drawing/2014/main" id="{7FF7C8C3-4FA0-4F02-F8EA-53522170C732}"/>
+              </a:ext>
+            </a:extLst>
+          </p:cNvPr>
+          <p:cNvSpPr txBox="1"/>
+          <p:nvPr/>
+        </p:nvSpPr>
+        <p:spPr>
+          <a:xfrm>
+            <a:off x="9061148" y="5956348"/>
+            <a:ext cx="1591612" cy="369332"/>
+          </a:xfrm>
+          <a:prstGeom prst="rect">
+            <a:avLst/>
+          </a:prstGeom>
+          <a:noFill/>
+        </p:spPr>
+        <p:txBody>
+          <a:bodyPr wrap="square" rtlCol="0">
+            <a:spAutoFit/>
+          </a:bodyPr>
+          <a:lstStyle/>
+          <a:p>
+            <a:r>
+              <a:rPr lang="en-NZ" dirty="0"/>
+              <a:t>Global (12)</a:t>
+            </a:r>
+          </a:p>
+        </p:txBody>
+      </p:sp>
+    </p:spTree>
+    <p:extLst>
+      <p:ext uri="{BB962C8B-B14F-4D97-AF65-F5344CB8AC3E}">
+        <p14:creationId xmlns:p14="http://schemas.microsoft.com/office/powerpoint/2010/main" val="2786335804"/>
       </p:ext>
     </p:extLst>
   </p:cSld>

</xml_diff>